<commit_message>
. d Point the Thank you slide's QR code and link at AiInLegacyCode.md
</commit_message>
<xml_diff>
--- a/slides/AiInLegacyCode.pptx
+++ b/slides/AiInLegacyCode.pptx
@@ -10224,7 +10224,7 @@
             </a:r>
             <a:r>
               <a:rPr lang="en-US" sz="1350" dirty="0" err="1"/>
-              <a:t>Analyzers.Net.md</a:t>
+              <a:t>AiInLegacyCode.md</a:t>
             </a:r>
             <a:endParaRPr lang="en-US" sz="1350" dirty="0"/>
           </a:p>
@@ -10245,7 +10245,7 @@
           <p:nvPr/>
         </p:nvPicPr>
         <p:blipFill>
-          <a:blip>
+          <a:blip r:embed="rId4">
             <a:extLst>
               <a:ext uri="{96DAC541-7B7A-43D3-8B79-37D633B846F1}">
                 <asvg:svgBlip xmlns:asvg="http://schemas.microsoft.com/office/drawing/2016/SVG/main" r:embed="rId3"/>

</xml_diff>

<commit_message>
. e Make the slides deterministic and add AGENTS.md with Determinize instructions
</commit_message>
<xml_diff>
--- a/slides/AiInLegacyCode.pptx
+++ b/slides/AiInLegacyCode.pptx
@@ -2,37 +2,37 @@
 <file path=ppt/presentation.xml><?xml version="1.0" encoding="utf-8"?>
 <p:presentation xmlns:a="http://schemas.openxmlformats.org/drawingml/2006/main" xmlns:r="http://schemas.openxmlformats.org/officeDocument/2006/relationships" xmlns:p="http://schemas.openxmlformats.org/presentationml/2006/main" saveSubsetFonts="1" autoCompressPictures="0">
   <p:sldMasterIdLst>
-    <p:sldMasterId id="2147483660" r:id="rId1"/>
+    <p:sldMasterId id="2147483660" r:id="DeterministicId28"/>
   </p:sldMasterIdLst>
   <p:notesMasterIdLst>
-    <p:notesMasterId r:id="rId27"/>
+    <p:notesMasterId r:id="DeterministicId1"/>
   </p:notesMasterIdLst>
   <p:sldIdLst>
-    <p:sldId id="276" r:id="rId2"/>
-    <p:sldId id="414" r:id="rId3"/>
-    <p:sldId id="436" r:id="rId4"/>
-    <p:sldId id="427" r:id="rId5"/>
-    <p:sldId id="327" r:id="rId6"/>
-    <p:sldId id="443" r:id="rId7"/>
-    <p:sldId id="442" r:id="rId8"/>
-    <p:sldId id="446" r:id="rId9"/>
-    <p:sldId id="445" r:id="rId10"/>
-    <p:sldId id="448" r:id="rId11"/>
-    <p:sldId id="457" r:id="rId12"/>
-    <p:sldId id="449" r:id="rId13"/>
-    <p:sldId id="450" r:id="rId14"/>
-    <p:sldId id="444" r:id="rId15"/>
-    <p:sldId id="451" r:id="rId16"/>
-    <p:sldId id="452" r:id="rId17"/>
-    <p:sldId id="453" r:id="rId18"/>
-    <p:sldId id="454" r:id="rId19"/>
-    <p:sldId id="455" r:id="rId20"/>
-    <p:sldId id="434" r:id="rId21"/>
-    <p:sldId id="441" r:id="rId22"/>
-    <p:sldId id="435" r:id="rId23"/>
-    <p:sldId id="410" r:id="rId24"/>
-    <p:sldId id="438" r:id="rId25"/>
-    <p:sldId id="439" r:id="rId26"/>
+    <p:sldId id="276" r:id="DeterministicId3"/>
+    <p:sldId id="414" r:id="DeterministicId14"/>
+    <p:sldId id="436" r:id="DeterministicId21"/>
+    <p:sldId id="427" r:id="DeterministicId22"/>
+    <p:sldId id="327" r:id="DeterministicId23"/>
+    <p:sldId id="443" r:id="DeterministicId24"/>
+    <p:sldId id="442" r:id="DeterministicId25"/>
+    <p:sldId id="446" r:id="DeterministicId26"/>
+    <p:sldId id="445" r:id="DeterministicId27"/>
+    <p:sldId id="448" r:id="DeterministicId4"/>
+    <p:sldId id="457" r:id="DeterministicId5"/>
+    <p:sldId id="449" r:id="DeterministicId6"/>
+    <p:sldId id="450" r:id="DeterministicId7"/>
+    <p:sldId id="444" r:id="DeterministicId8"/>
+    <p:sldId id="451" r:id="DeterministicId9"/>
+    <p:sldId id="452" r:id="DeterministicId10"/>
+    <p:sldId id="453" r:id="DeterministicId11"/>
+    <p:sldId id="454" r:id="DeterministicId12"/>
+    <p:sldId id="455" r:id="DeterministicId13"/>
+    <p:sldId id="434" r:id="DeterministicId15"/>
+    <p:sldId id="441" r:id="DeterministicId16"/>
+    <p:sldId id="435" r:id="DeterministicId17"/>
+    <p:sldId id="410" r:id="DeterministicId18"/>
+    <p:sldId id="438" r:id="DeterministicId19"/>
+    <p:sldId id="439" r:id="DeterministicId20"/>
   </p:sldIdLst>
   <p:sldSz cx="9144000" cy="6858000" type="screen4x3"/>
   <p:notesSz cx="6858000" cy="9144000"/>
@@ -269,7 +269,7 @@
             </a:lvl1pPr>
           </a:lstStyle>
           <a:p>
-            <a:fld id="{34351BAA-7863-A845-95EE-E0917C9017CF}" type="datetimeFigureOut">
+            <a:fld id="{00000001-0000-0000-0000-000000000000}" type="datetimeFigureOut">
               <a:rPr lang="en-US" smtClean="0"/>
               <a:t>10/29/26</a:t>
             </a:fld>
@@ -427,7 +427,7 @@
             </a:lvl1pPr>
           </a:lstStyle>
           <a:p>
-            <a:fld id="{3B35D2C9-2D07-354B-99FC-F9CD075E9940}" type="slidenum">
+            <a:fld id="{00000002-0000-0000-0000-000000000000}" type="slidenum">
               <a:rPr lang="en-US" smtClean="0"/>
               <a:t>‹#›</a:t>
             </a:fld>
@@ -715,7 +715,7 @@
           <a:bodyPr/>
           <a:lstStyle/>
           <a:p>
-            <a:fld id="{5BCAD085-E8A6-8845-BD4E-CB4CCA059FC4}" type="datetimeFigureOut">
+            <a:fld id="{00000001-0000-0000-0000-000000000000}" type="datetimeFigureOut">
               <a:rPr lang="en-US" smtClean="0"/>
               <a:t>10/29/26</a:t>
             </a:fld>
@@ -757,7 +757,7 @@
           <a:bodyPr/>
           <a:lstStyle/>
           <a:p>
-            <a:fld id="{C1FF6DA9-008F-8B48-92A6-B652298478BF}" type="slidenum">
+            <a:fld id="{00000002-0000-0000-0000-000000000000}" type="slidenum">
               <a:rPr lang="en-US" smtClean="0"/>
               <a:t>‹#›</a:t>
             </a:fld>
@@ -883,7 +883,7 @@
           <a:bodyPr/>
           <a:lstStyle/>
           <a:p>
-            <a:fld id="{5BCAD085-E8A6-8845-BD4E-CB4CCA059FC4}" type="datetimeFigureOut">
+            <a:fld id="{00000001-0000-0000-0000-000000000000}" type="datetimeFigureOut">
               <a:rPr lang="en-US" smtClean="0"/>
               <a:t>10/29/26</a:t>
             </a:fld>
@@ -925,7 +925,7 @@
           <a:bodyPr/>
           <a:lstStyle/>
           <a:p>
-            <a:fld id="{C1FF6DA9-008F-8B48-92A6-B652298478BF}" type="slidenum">
+            <a:fld id="{00000002-0000-0000-0000-000000000000}" type="slidenum">
               <a:rPr lang="en-US" smtClean="0"/>
               <a:t>‹#›</a:t>
             </a:fld>
@@ -1061,7 +1061,7 @@
           <a:bodyPr/>
           <a:lstStyle/>
           <a:p>
-            <a:fld id="{5BCAD085-E8A6-8845-BD4E-CB4CCA059FC4}" type="datetimeFigureOut">
+            <a:fld id="{00000001-0000-0000-0000-000000000000}" type="datetimeFigureOut">
               <a:rPr lang="en-US" smtClean="0"/>
               <a:t>10/29/26</a:t>
             </a:fld>
@@ -1103,7 +1103,7 @@
           <a:bodyPr/>
           <a:lstStyle/>
           <a:p>
-            <a:fld id="{C1FF6DA9-008F-8B48-92A6-B652298478BF}" type="slidenum">
+            <a:fld id="{00000002-0000-0000-0000-000000000000}" type="slidenum">
               <a:rPr lang="en-US" smtClean="0"/>
               <a:t>‹#›</a:t>
             </a:fld>
@@ -1229,7 +1229,7 @@
           <a:bodyPr/>
           <a:lstStyle/>
           <a:p>
-            <a:fld id="{5BCAD085-E8A6-8845-BD4E-CB4CCA059FC4}" type="datetimeFigureOut">
+            <a:fld id="{00000001-0000-0000-0000-000000000000}" type="datetimeFigureOut">
               <a:rPr lang="en-US" smtClean="0"/>
               <a:t>10/29/26</a:t>
             </a:fld>
@@ -1271,7 +1271,7 @@
           <a:bodyPr/>
           <a:lstStyle/>
           <a:p>
-            <a:fld id="{C1FF6DA9-008F-8B48-92A6-B652298478BF}" type="slidenum">
+            <a:fld id="{00000002-0000-0000-0000-000000000000}" type="slidenum">
               <a:rPr lang="en-US" smtClean="0"/>
               <a:t>‹#›</a:t>
             </a:fld>
@@ -1474,7 +1474,7 @@
           <a:bodyPr/>
           <a:lstStyle/>
           <a:p>
-            <a:fld id="{5BCAD085-E8A6-8845-BD4E-CB4CCA059FC4}" type="datetimeFigureOut">
+            <a:fld id="{00000001-0000-0000-0000-000000000000}" type="datetimeFigureOut">
               <a:rPr lang="en-US" smtClean="0"/>
               <a:t>10/29/26</a:t>
             </a:fld>
@@ -1516,7 +1516,7 @@
           <a:bodyPr/>
           <a:lstStyle/>
           <a:p>
-            <a:fld id="{C1FF6DA9-008F-8B48-92A6-B652298478BF}" type="slidenum">
+            <a:fld id="{00000002-0000-0000-0000-000000000000}" type="slidenum">
               <a:rPr lang="en-US" smtClean="0"/>
               <a:t>‹#›</a:t>
             </a:fld>
@@ -1759,7 +1759,7 @@
           <a:bodyPr/>
           <a:lstStyle/>
           <a:p>
-            <a:fld id="{5BCAD085-E8A6-8845-BD4E-CB4CCA059FC4}" type="datetimeFigureOut">
+            <a:fld id="{00000001-0000-0000-0000-000000000000}" type="datetimeFigureOut">
               <a:rPr lang="en-US" smtClean="0"/>
               <a:t>10/29/26</a:t>
             </a:fld>
@@ -1801,7 +1801,7 @@
           <a:bodyPr/>
           <a:lstStyle/>
           <a:p>
-            <a:fld id="{C1FF6DA9-008F-8B48-92A6-B652298478BF}" type="slidenum">
+            <a:fld id="{00000002-0000-0000-0000-000000000000}" type="slidenum">
               <a:rPr lang="en-US" smtClean="0"/>
               <a:t>‹#›</a:t>
             </a:fld>
@@ -2178,7 +2178,7 @@
           <a:bodyPr/>
           <a:lstStyle/>
           <a:p>
-            <a:fld id="{5BCAD085-E8A6-8845-BD4E-CB4CCA059FC4}" type="datetimeFigureOut">
+            <a:fld id="{00000001-0000-0000-0000-000000000000}" type="datetimeFigureOut">
               <a:rPr lang="en-US" smtClean="0"/>
               <a:t>10/29/26</a:t>
             </a:fld>
@@ -2220,7 +2220,7 @@
           <a:bodyPr/>
           <a:lstStyle/>
           <a:p>
-            <a:fld id="{C1FF6DA9-008F-8B48-92A6-B652298478BF}" type="slidenum">
+            <a:fld id="{00000002-0000-0000-0000-000000000000}" type="slidenum">
               <a:rPr lang="en-US" smtClean="0"/>
               <a:t>‹#›</a:t>
             </a:fld>
@@ -2295,7 +2295,7 @@
           <a:bodyPr/>
           <a:lstStyle/>
           <a:p>
-            <a:fld id="{5BCAD085-E8A6-8845-BD4E-CB4CCA059FC4}" type="datetimeFigureOut">
+            <a:fld id="{00000001-0000-0000-0000-000000000000}" type="datetimeFigureOut">
               <a:rPr lang="en-US" smtClean="0"/>
               <a:t>10/29/26</a:t>
             </a:fld>
@@ -2337,7 +2337,7 @@
           <a:bodyPr/>
           <a:lstStyle/>
           <a:p>
-            <a:fld id="{C1FF6DA9-008F-8B48-92A6-B652298478BF}" type="slidenum">
+            <a:fld id="{00000002-0000-0000-0000-000000000000}" type="slidenum">
               <a:rPr lang="en-US" smtClean="0"/>
               <a:t>‹#›</a:t>
             </a:fld>
@@ -2390,7 +2390,7 @@
           <a:bodyPr/>
           <a:lstStyle/>
           <a:p>
-            <a:fld id="{5BCAD085-E8A6-8845-BD4E-CB4CCA059FC4}" type="datetimeFigureOut">
+            <a:fld id="{00000001-0000-0000-0000-000000000000}" type="datetimeFigureOut">
               <a:rPr lang="en-US" smtClean="0"/>
               <a:t>10/29/26</a:t>
             </a:fld>
@@ -2432,7 +2432,7 @@
           <a:bodyPr/>
           <a:lstStyle/>
           <a:p>
-            <a:fld id="{C1FF6DA9-008F-8B48-92A6-B652298478BF}" type="slidenum">
+            <a:fld id="{00000002-0000-0000-0000-000000000000}" type="slidenum">
               <a:rPr lang="en-US" smtClean="0"/>
               <a:t>‹#›</a:t>
             </a:fld>
@@ -2665,7 +2665,7 @@
           <a:bodyPr/>
           <a:lstStyle/>
           <a:p>
-            <a:fld id="{5BCAD085-E8A6-8845-BD4E-CB4CCA059FC4}" type="datetimeFigureOut">
+            <a:fld id="{00000001-0000-0000-0000-000000000000}" type="datetimeFigureOut">
               <a:rPr lang="en-US" smtClean="0"/>
               <a:t>10/29/26</a:t>
             </a:fld>
@@ -2707,7 +2707,7 @@
           <a:bodyPr/>
           <a:lstStyle/>
           <a:p>
-            <a:fld id="{C1FF6DA9-008F-8B48-92A6-B652298478BF}" type="slidenum">
+            <a:fld id="{00000002-0000-0000-0000-000000000000}" type="slidenum">
               <a:rPr lang="en-US" smtClean="0"/>
               <a:t>‹#›</a:t>
             </a:fld>
@@ -2917,7 +2917,7 @@
           <a:bodyPr/>
           <a:lstStyle/>
           <a:p>
-            <a:fld id="{5BCAD085-E8A6-8845-BD4E-CB4CCA059FC4}" type="datetimeFigureOut">
+            <a:fld id="{00000001-0000-0000-0000-000000000000}" type="datetimeFigureOut">
               <a:rPr lang="en-US" smtClean="0"/>
               <a:t>10/29/26</a:t>
             </a:fld>
@@ -2959,7 +2959,7 @@
           <a:bodyPr/>
           <a:lstStyle/>
           <a:p>
-            <a:fld id="{C1FF6DA9-008F-8B48-92A6-B652298478BF}" type="slidenum">
+            <a:fld id="{00000002-0000-0000-0000-000000000000}" type="slidenum">
               <a:rPr lang="en-US" smtClean="0"/>
               <a:t>‹#›</a:t>
             </a:fld>
@@ -3128,7 +3128,7 @@
             </a:lvl1pPr>
           </a:lstStyle>
           <a:p>
-            <a:fld id="{5BCAD085-E8A6-8845-BD4E-CB4CCA059FC4}" type="datetimeFigureOut">
+            <a:fld id="{00000001-0000-0000-0000-000000000000}" type="datetimeFigureOut">
               <a:rPr lang="en-US" smtClean="0"/>
               <a:t>10/29/26</a:t>
             </a:fld>
@@ -3206,7 +3206,7 @@
             </a:lvl1pPr>
           </a:lstStyle>
           <a:p>
-            <a:fld id="{C1FF6DA9-008F-8B48-92A6-B652298478BF}" type="slidenum">
+            <a:fld id="{00000002-0000-0000-0000-000000000000}" type="slidenum">
               <a:rPr lang="en-US" smtClean="0"/>
               <a:t>‹#›</a:t>
             </a:fld>
@@ -3223,17 +3223,17 @@
   </p:cSld>
   <p:clrMap bg1="lt1" tx1="dk1" bg2="lt2" tx2="dk2" accent1="accent1" accent2="accent2" accent3="accent3" accent4="accent4" accent5="accent5" accent6="accent6" hlink="hlink" folHlink="folHlink"/>
   <p:sldLayoutIdLst>
-    <p:sldLayoutId id="2147483661" r:id="rId1"/>
-    <p:sldLayoutId id="2147483662" r:id="rId2"/>
-    <p:sldLayoutId id="2147483663" r:id="rId3"/>
-    <p:sldLayoutId id="2147483664" r:id="rId4"/>
-    <p:sldLayoutId id="2147483665" r:id="rId5"/>
-    <p:sldLayoutId id="2147483666" r:id="rId6"/>
-    <p:sldLayoutId id="2147483667" r:id="rId7"/>
-    <p:sldLayoutId id="2147483668" r:id="rId8"/>
-    <p:sldLayoutId id="2147483669" r:id="rId9"/>
-    <p:sldLayoutId id="2147483670" r:id="rId10"/>
-    <p:sldLayoutId id="2147483671" r:id="rId11"/>
+    <p:sldLayoutId id="2147483661" r:id="DeterministicId1"/>
+    <p:sldLayoutId id="2147483662" r:id="DeterministicId4"/>
+    <p:sldLayoutId id="2147483663" r:id="DeterministicId5"/>
+    <p:sldLayoutId id="2147483664" r:id="DeterministicId6"/>
+    <p:sldLayoutId id="2147483665" r:id="DeterministicId7"/>
+    <p:sldLayoutId id="2147483666" r:id="DeterministicId8"/>
+    <p:sldLayoutId id="2147483667" r:id="DeterministicId9"/>
+    <p:sldLayoutId id="2147483668" r:id="DeterministicId10"/>
+    <p:sldLayoutId id="2147483669" r:id="DeterministicId11"/>
+    <p:sldLayoutId id="2147483670" r:id="DeterministicId2"/>
+    <p:sldLayoutId id="2147483671" r:id="DeterministicId3"/>
   </p:sldLayoutIdLst>
   <p:txStyles>
     <p:titleStyle>
@@ -4136,7 +4136,7 @@
                 <a:effectLst/>
                 <a:latin typeface="Menlo" panose="020B0609030804020204" pitchFamily="49" charset="0"/>
               </a:rPr>
-              <a:t> </a:t>
+              <a:t/>
             </a:r>
             <a:r>
               <a:rPr lang="en-US" sz="500" b="0" dirty="0">
@@ -4590,7 +4590,7 @@
                 <a:effectLst/>
                 <a:latin typeface="Menlo" panose="020B0609030804020204" pitchFamily="49" charset="0"/>
               </a:rPr>
-              <a:t> </a:t>
+              <a:t/>
             </a:r>
             <a:r>
               <a:rPr lang="en-US" sz="500" b="0" dirty="0">
@@ -4610,7 +4610,7 @@
                 <a:effectLst/>
                 <a:latin typeface="Menlo" panose="020B0609030804020204" pitchFamily="49" charset="0"/>
               </a:rPr>
-              <a:t> </a:t>
+              <a:t/>
             </a:r>
             <a:r>
               <a:rPr lang="en-US" sz="500" b="0" dirty="0">
@@ -5045,7 +5045,7 @@
                 <a:effectLst/>
                 <a:latin typeface="Menlo" panose="020B0609030804020204" pitchFamily="49" charset="0"/>
               </a:rPr>
-              <a:t> </a:t>
+              <a:t/>
             </a:r>
             <a:r>
               <a:rPr lang="en-US" sz="500" b="0" dirty="0">
@@ -5065,7 +5065,7 @@
                 <a:effectLst/>
                 <a:latin typeface="Menlo" panose="020B0609030804020204" pitchFamily="49" charset="0"/>
               </a:rPr>
-              <a:t> </a:t>
+              <a:t/>
             </a:r>
             <a:r>
               <a:rPr lang="en-US" sz="500" b="0" dirty="0">
@@ -6324,7 +6324,7 @@
           <p:nvPr/>
         </p:nvPicPr>
         <p:blipFill>
-          <a:blip r:embed="rId2"/>
+          <a:blip r:embed="DeterministicId1"/>
           <a:stretch>
             <a:fillRect/>
           </a:stretch>
@@ -6460,7 +6460,7 @@
           <p:nvPr/>
         </p:nvPicPr>
         <p:blipFill>
-          <a:blip r:embed="rId2"/>
+          <a:blip r:embed="DeterministicId1"/>
           <a:srcRect l="27737" t="12452" r="63262" b="71303"/>
           <a:stretch>
             <a:fillRect/>
@@ -10148,7 +10148,7 @@
           <p:nvPr/>
         </p:nvPicPr>
         <p:blipFill>
-          <a:blip r:embed="rId2"/>
+          <a:blip r:embed="DeterministicId1"/>
           <a:stretch>
             <a:fillRect/>
           </a:stretch>
@@ -10245,10 +10245,10 @@
           <p:nvPr/>
         </p:nvPicPr>
         <p:blipFill>
-          <a:blip r:embed="rId4">
+          <a:blip r:embed="DeterministicId3">
             <a:extLst>
               <a:ext uri="{96DAC541-7B7A-43D3-8B79-37D633B846F1}">
-                <asvg:svgBlip xmlns:asvg="http://schemas.microsoft.com/office/drawing/2016/SVG/main" r:embed="rId3"/>
+                <asvg:svgBlip xmlns:asvg="http://schemas.microsoft.com/office/drawing/2016/SVG/main" r:embed="DeterministicId2"/>
               </a:ext>
             </a:extLst>
           </a:blip>
@@ -12392,7 +12392,7 @@
           <p:nvPr/>
         </p:nvPicPr>
         <p:blipFill>
-          <a:blip r:embed="rId2"/>
+          <a:blip r:embed="DeterministicId1"/>
           <a:stretch>
             <a:fillRect/>
           </a:stretch>
@@ -12429,7 +12429,7 @@
           <p:nvPr/>
         </p:nvPicPr>
         <p:blipFill>
-          <a:blip r:embed="rId3"/>
+          <a:blip r:embed="DeterministicId2"/>
           <a:stretch>
             <a:fillRect/>
           </a:stretch>
@@ -12921,7 +12921,7 @@
           <p:nvPr/>
         </p:nvPicPr>
         <p:blipFill>
-          <a:blip r:embed="rId2"/>
+          <a:blip r:embed="DeterministicId1"/>
           <a:srcRect l="12732" t="40949" r="77714" b="45010"/>
           <a:stretch>
             <a:fillRect/>
@@ -13037,7 +13037,7 @@
           <p:nvPr/>
         </p:nvPicPr>
         <p:blipFill>
-          <a:blip r:embed="rId2"/>
+          <a:blip r:embed="DeterministicId1"/>
           <a:srcRect l="133" t="32215" r="-133" b="471"/>
           <a:stretch>
             <a:fillRect/>
@@ -13104,7 +13104,7 @@
           <p:nvPr/>
         </p:nvPicPr>
         <p:blipFill>
-          <a:blip r:embed="rId2"/>
+          <a:blip r:embed="DeterministicId1"/>
           <a:stretch>
             <a:fillRect/>
           </a:stretch>
@@ -13240,7 +13240,7 @@
           <p:nvPr/>
         </p:nvPicPr>
         <p:blipFill>
-          <a:blip r:embed="rId2"/>
+          <a:blip r:embed="DeterministicId1"/>
           <a:srcRect l="24735" t="47280" r="65632" b="37990"/>
           <a:stretch>
             <a:fillRect/>
@@ -13926,7 +13926,7 @@
 <file path=ppt/webextensions/taskpanes.xml><?xml version="1.0" encoding="utf-8"?>
 <wetp:taskpanes xmlns:wetp="http://schemas.microsoft.com/office/webextensions/taskpanes/2010/11">
   <wetp:taskpane dockstate="right" visibility="0" width="350" row="0">
-    <wetp:webextensionref xmlns:r="http://schemas.openxmlformats.org/officeDocument/2006/relationships" r:id="rId1"/>
+    <wetp:webextensionref xmlns:r="http://schemas.openxmlformats.org/officeDocument/2006/relationships" r:id="DeterministicId1"/>
   </wetp:taskpane>
 </wetp:taskpanes>
 </file>

</xml_diff>